<commit_message>
Switched backend from Anthropic to OpenAI
</commit_message>
<xml_diff>
--- a/deck/bookly-pitch-deck.pptx
+++ b/deck/bookly-pitch-deck.pptx
@@ -4097,7 +4097,7 @@
                 </a:solidFill>
                 <a:latin typeface="Helvetica Neue"/>
               </a:rPr>
-              <a:t>Claude decides:</a:t>
+              <a:t>The model decides:</a:t>
             </a:r>
           </a:p>
           <a:p>
@@ -5840,7 +5840,7 @@
                 </a:solidFill>
                 <a:latin typeface="Helvetica Neue"/>
               </a:rPr>
-              <a:t>A moderation-endpoint-style check — a separate, cheap Claude call — screens every inbound and outbound message against configurable categories.</a:t>
+              <a:t>A moderation-endpoint-style check — a separate, cheap OpenAI call — screens every inbound and outbound message against configurable categories.</a:t>
             </a:r>
           </a:p>
         </p:txBody>

</xml_diff>